<commit_message>
Notas del orador en las diapositivas
</commit_message>
<xml_diff>
--- a/slides/EDA-Pokemon-Rodeyro.pptx
+++ b/slides/EDA-Pokemon-Rodeyro.pptx
@@ -510,28 +510,28 @@
           <a:p/>
           <a:p>
             <a:r>
-              <a:t>"Buenas. Soy Agustín Rodeyro y voy a presentar el análisis exploratorio del dataset de</a:t>
-            </a:r>
-          </a:p>
-          <a:p>
-            <a:r>
-              <a:t>Pokémon de Kaggle: 800 registros, 13 columnas, 6 generaciones. El notebook completo está</a:t>
-            </a:r>
-          </a:p>
-          <a:p>
-            <a:r>
-              <a:t>en el repositorio que figura abajo a la derecha."</a:t>
+              <a:t>"Bueno, buenas. Yo elegí el dataset de Pokémon, lo saqué de Kaggle. Son 800 filas,</a:t>
+            </a:r>
+          </a:p>
+          <a:p>
+            <a:r>
+              <a:t>13 columnas, y cubre las primeras seis generaciones."</a:t>
             </a:r>
           </a:p>
           <a:p/>
           <a:p>
             <a:r>
-              <a:t>"El trabajo tiene dos partes: primero caracterizo el dataset y muestro tres rarezas en</a:t>
-            </a:r>
-          </a:p>
-          <a:p>
-            <a:r>
-              <a:t>cómo está construido; después analizo los outliers y justifico qué hacer con ellos."</a:t>
+              <a:t>"Voy a mostrar dos cosas: primero cómo está armado el dataset, porque tiene un par de</a:t>
+            </a:r>
+          </a:p>
+          <a:p>
+            <a:r>
+              <a:t>cosas raras que no se ven a simple vista; y después el análisis de outliers, que fue lo</a:t>
+            </a:r>
+          </a:p>
+          <a:p>
+            <a:r>
+              <a:t>que más me sorprendió."</a:t>
             </a:r>
           </a:p>
           <a:p/>
@@ -613,117 +613,168 @@
           <a:p/>
           <a:p>
             <a:r>
-              <a:t>— ABRIR CON LA FICHA —</a:t>
-            </a:r>
-          </a:p>
-          <a:p>
-            <a:r>
-              <a:t>"El dataset son 800 filas por 13 columnas, 179 KB: entra entero en memoria. Seis</a:t>
-            </a:r>
-          </a:p>
-          <a:p>
-            <a:r>
-              <a:t>variables numéricas que son las stats base, una derivada que es Total, tres categóricas,</a:t>
-            </a:r>
-          </a:p>
-          <a:p>
-            <a:r>
-              <a:t>una booleana y dos identificadores."</a:t>
+              <a:t>— ARRANCÁ POR LO BÁSICO —</a:t>
+            </a:r>
+          </a:p>
+          <a:p>
+            <a:r>
+              <a:t>"Primero lo general: son 800 filas por 13 columnas, ocupa 179 KB. O sea que es chiquito,</a:t>
+            </a:r>
+          </a:p>
+          <a:p>
+            <a:r>
+              <a:t>entra entero en memoria sin ningún problema."</a:t>
             </a:r>
           </a:p>
           <a:p/>
           <a:p>
             <a:r>
-              <a:t>"Lo primero que sorprende es que está limpio: cero duplicados exactos y cero nulos</a:t>
-            </a:r>
-          </a:p>
-          <a:p>
-            <a:r>
-              <a:t>reales."</a:t>
+              <a:t>"De las columnas, seis son las stats del Pokémon —vida, ataque, defensa y las dos</a:t>
+            </a:r>
+          </a:p>
+          <a:p>
+            <a:r>
+              <a:t>especiales, más velocidad—. Después está Total, tres categóricas, una booleana que dice</a:t>
+            </a:r>
+          </a:p>
+          <a:p>
+            <a:r>
+              <a:t>si es legendario, y dos que son identificadores."</a:t>
             </a:r>
           </a:p>
           <a:p/>
           <a:p>
             <a:r>
-              <a:t>— EL GANCHO —</a:t>
-            </a:r>
-          </a:p>
-          <a:p>
-            <a:r>
-              <a:t>"Pero tiene tres rarezas en cómo está construido."</a:t>
+              <a:t>"Lo primero que hice fue buscar problemas de calidad. Y la verdad que no encontré: no hay</a:t>
+            </a:r>
+          </a:p>
+          <a:p>
+            <a:r>
+              <a:t>filas duplicadas, no hay nombres repetidos. Está limpio."</a:t>
             </a:r>
           </a:p>
           <a:p/>
           <a:p>
             <a:r>
+              <a:t>— EL GANCHO (hacé una pausa acá) —</a:t>
+            </a:r>
+          </a:p>
+          <a:p>
+            <a:r>
+              <a:t>"Pero cuando me puse a mirar bien cómo está construido, aparecieron tres cosas."</a:t>
+            </a:r>
+          </a:p>
+          <a:p/>
+          <a:p>
+            <a:r>
               <a:t>— RAREZA 1 (señalá la barra naranja del gráfico) —</a:t>
             </a:r>
           </a:p>
           <a:p>
             <a:r>
-              <a:t>"Type 2 tiene 386 nulos, casi la mitad del dataset. Parece el problema de calidad más</a:t>
-            </a:r>
-          </a:p>
-          <a:p>
-            <a:r>
-              <a:t>obvio, pero no lo es: son Pokémon mono-tipo. La ausencia de un segundo tipo ES el dato.</a:t>
-            </a:r>
-          </a:p>
-          <a:p>
-            <a:r>
-              <a:t>Si hiciera un dropna borraría el 48 % del dataset sin motivo. Es la diferencia entre un</a:t>
-            </a:r>
-          </a:p>
-          <a:p>
-            <a:r>
-              <a:t>valor faltante y uno que no aplica."</a:t>
+              <a:t>"La primera es esta barra de acá. Type 2 tiene 386 nulos, casi la mitad del dataset. Al</a:t>
+            </a:r>
+          </a:p>
+          <a:p>
+            <a:r>
+              <a:t>principio pensé «bueno, acá hay un problema de datos faltantes»."</a:t>
             </a:r>
           </a:p>
           <a:p/>
           <a:p>
             <a:r>
+              <a:t>"Pero no. Esos 386 son Pokémon que tienen un solo tipo. O sea, el nulo no es que falte el</a:t>
+            </a:r>
+          </a:p>
+          <a:p>
+            <a:r>
+              <a:t>dato, es que no existe un segundo tipo."</a:t>
+            </a:r>
+          </a:p>
+          <a:p/>
+          <a:p>
+            <a:r>
+              <a:t>"Y esto importa, porque si yo hacía un dropna para limpiar, me borraba el 48 % del dataset</a:t>
+            </a:r>
+          </a:p>
+          <a:p>
+            <a:r>
+              <a:t>sin ningún motivo. Lo que corresponde es rellenarlo con una categoría que diga «None»."</a:t>
+            </a:r>
+          </a:p>
+          <a:p/>
+          <a:p>
+            <a:r>
               <a:t>— RAREZA 2 —</a:t>
             </a:r>
           </a:p>
           <a:p>
             <a:r>
-              <a:t>"El numeral no es clave primaria: hay 800 filas pero solo 721 números distintos. Las 49</a:t>
-            </a:r>
-          </a:p>
-          <a:p>
-            <a:r>
-              <a:t>formas Mega comparten el número de Pokédex con su forma base: Charizard, Mega Charizard X</a:t>
-            </a:r>
-          </a:p>
-          <a:p>
-            <a:r>
-              <a:t>y Mega Charizard Y son los tres el número 6."</a:t>
+              <a:t>"La segunda: el número de Pokédex no sirve como identificador único. Hay 800 filas pero</a:t>
+            </a:r>
+          </a:p>
+          <a:p>
+            <a:r>
+              <a:t>solo 721 números distintos."</a:t>
             </a:r>
           </a:p>
           <a:p/>
           <a:p>
             <a:r>
-              <a:t>— RAREZA 3 —</a:t>
-            </a:r>
-          </a:p>
-          <a:p>
-            <a:r>
-              <a:t>"Y Total es una columna derivada. Verifiqué que en las 800 filas es exactamente la suma</a:t>
-            </a:r>
-          </a:p>
-          <a:p>
-            <a:r>
-              <a:t>de las seis stats, sin una sola excepción. Por eso en el heatmap correlaciona entre 0,6 y</a:t>
-            </a:r>
-          </a:p>
-          <a:p>
-            <a:r>
-              <a:t>0,75 con todas: no es un hallazgo, es aritmética. Y para modelar, usar Total junto a las</a:t>
-            </a:r>
-          </a:p>
-          <a:p>
-            <a:r>
-              <a:t>seis stats sería multicolinealidad perfecta."</a:t>
+              <a:t>"¿Por qué? Porque las Mega evoluciones se quedaron con el número de la forma original.</a:t>
+            </a:r>
+          </a:p>
+          <a:p>
+            <a:r>
+              <a:t>Por ejemplo, Charizard, Mega Charizard X y Mega Charizard Y son los tres el número 6."</a:t>
+            </a:r>
+          </a:p>
+          <a:p/>
+          <a:p>
+            <a:r>
+              <a:t>— RAREZA 3 (la que más te costó ver) —</a:t>
+            </a:r>
+          </a:p>
+          <a:p>
+            <a:r>
+              <a:t>"Y la tercera, que es la que más me costó darme cuenta: la columna Total no es un dato</a:t>
+            </a:r>
+          </a:p>
+          <a:p>
+            <a:r>
+              <a:t>nuevo, es la suma de las otras seis. Me fijé fila por fila y se cumple en las 800, sin una</a:t>
+            </a:r>
+          </a:p>
+          <a:p>
+            <a:r>
+              <a:t>sola excepción."</a:t>
+            </a:r>
+          </a:p>
+          <a:p/>
+          <a:p>
+            <a:r>
+              <a:t>"Esto me explicó algo que había visto en el trabajo anterior y no entendía: en la matriz</a:t>
+            </a:r>
+          </a:p>
+          <a:p>
+            <a:r>
+              <a:t>de correlación, Total correlacionaba fuerte con todas las stats, entre 0,6 y 0,75. Y no es</a:t>
+            </a:r>
+          </a:p>
+          <a:p>
+            <a:r>
+              <a:t>que haya una relación interesante ahí — es simplemente que es la suma."</a:t>
+            </a:r>
+          </a:p>
+          <a:p/>
+          <a:p>
+            <a:r>
+              <a:t>"Si después quisiera armar un modelo, usar Total junto con las seis stats sería un</a:t>
+            </a:r>
+          </a:p>
+          <a:p>
+            <a:r>
+              <a:t>problema, porque es información repetida."</a:t>
             </a:r>
           </a:p>
           <a:p/>
@@ -810,155 +861,239 @@
           </a:p>
           <a:p>
             <a:r>
-              <a:t>"Para los outliers apliqué la regla del IQR de Tukey con k igual a 1,5: se marca todo lo</a:t>
-            </a:r>
-          </a:p>
-          <a:p>
-            <a:r>
-              <a:t>que caiga fuera de Q1 menos 1,5 por el rango intercuartílico, y Q3 más 1,5. Dieron 52</a:t>
-            </a:r>
-          </a:p>
-          <a:p>
-            <a:r>
-              <a:t>Pokémon, el 6,5 %, outliers en al menos una stat. Ninguna stat individual supera el 2,4 %,</a:t>
-            </a:r>
-          </a:p>
-          <a:p>
-            <a:r>
-              <a:t>lo que descarta errores sistemáticos de carga."</a:t>
+              <a:t>"Bueno, y acá viene la parte que más me interesó."</a:t>
             </a:r>
           </a:p>
           <a:p/>
           <a:p>
             <a:r>
-              <a:t>— EL REMATE (bajá la velocidad acá) —</a:t>
-            </a:r>
-          </a:p>
-          <a:p>
-            <a:r>
-              <a:t>"Pero acá está lo interesante: Total no tiene ningún outlier, aunque sus seis componentes</a:t>
-            </a:r>
-          </a:p>
-          <a:p>
-            <a:r>
-              <a:t>sí tienen."</a:t>
+              <a:t>"Para los outliers usé la regla del IQR. La idea es: agarro el rango entre el primer y el</a:t>
+            </a:r>
+          </a:p>
+          <a:p>
+            <a:r>
+              <a:t>tercer cuartil, lo multiplico por 1,5, y todo lo que quede afuera de eso lo marco como</a:t>
+            </a:r>
+          </a:p>
+          <a:p>
+            <a:r>
+              <a:t>outlier. Es el criterio estándar, el mismo que usa el boxplot para dibujar los puntitos."</a:t>
             </a:r>
           </a:p>
           <a:p/>
           <a:p>
             <a:r>
-              <a:t>"El caso que lo explica es Shuckle: tiene 230 de defensa y 230 de defensa especial, los</a:t>
-            </a:r>
-          </a:p>
-          <a:p>
-            <a:r>
-              <a:t>dos máximos del dataset, pero 5 de velocidad y 10 de ataque. Suma 505, que es un Pokémon</a:t>
-            </a:r>
-          </a:p>
-          <a:p>
-            <a:r>
-              <a:t>del montón."</a:t>
+              <a:t>"Me dieron 52 Pokémon, que es el 6,5 %. Y ninguna stat sola pasa del 2,4 %, así que ahí</a:t>
+            </a:r>
+          </a:p>
+          <a:p>
+            <a:r>
+              <a:t>ya descarté que hubiera errores de carga."</a:t>
             </a:r>
           </a:p>
           <a:p/>
           <a:p>
             <a:r>
-              <a:t>"O sea: los outliers de este dataset no son de poder, son de perfil. El juego reparte un</a:t>
-            </a:r>
-          </a:p>
-          <a:p>
-            <a:r>
-              <a:t>presupuesto fijo de puntos, y si te destacás en algo lo pagás en otra cosa."</a:t>
+              <a:t>— EL REMATE (bajá la velocidad, es lo más importante) —</a:t>
+            </a:r>
+          </a:p>
+          <a:p>
+            <a:r>
+              <a:t>"Pero acá está lo raro, y es lo que me gustaría que se lleven: Total no tiene ni un</a:t>
+            </a:r>
+          </a:p>
+          <a:p>
+            <a:r>
+              <a:t>outlier. Cero. Aunque las seis stats que lo forman sí tienen."</a:t>
             </a:r>
           </a:p>
           <a:p/>
           <a:p>
             <a:r>
-              <a:t>— NATURALEZA —</a:t>
-            </a:r>
-          </a:p>
-          <a:p>
-            <a:r>
-              <a:t>"Después miré quiénes son, porque eso es lo que decide si se eliminan. Shedinja tiene 1 de</a:t>
-            </a:r>
-          </a:p>
-          <a:p>
-            <a:r>
-              <a:t>HP: es el único outlier por debajo del límite en las 800 filas y las seis stats. Y no es</a:t>
-            </a:r>
-          </a:p>
-          <a:p>
-            <a:r>
-              <a:t>un error de carga: en el juego tiene una habilidad que lo hace casi invulnerable, así que</a:t>
-            </a:r>
-          </a:p>
-          <a:p>
-            <a:r>
-              <a:t>le pusieron un punto de vida a propósito. El valor más anómalo del dataset es diseño</a:t>
-            </a:r>
-          </a:p>
-          <a:p>
-            <a:r>
-              <a:t>deliberado."</a:t>
+              <a:t>"Al principio pensé que me había equivocado en el cálculo. Pero cuando fui a ver quiénes</a:t>
+            </a:r>
+          </a:p>
+          <a:p>
+            <a:r>
+              <a:t>eran, entendí."</a:t>
             </a:r>
           </a:p>
           <a:p/>
           <a:p>
             <a:r>
+              <a:t>"El caso que lo explica es Shuckle. Tiene 230 de defensa y 230 de defensa especial: son</a:t>
+            </a:r>
+          </a:p>
+          <a:p>
+            <a:r>
+              <a:t>los dos valores más altos de todo el dataset. Pero tiene 5 de velocidad y 10 de ataque. Y</a:t>
+            </a:r>
+          </a:p>
+          <a:p>
+            <a:r>
+              <a:t>cuando sumás todo te da 505, que es un Pokémon totalmente normal."</a:t>
+            </a:r>
+          </a:p>
+          <a:p/>
+          <a:p>
+            <a:r>
+              <a:t>"O sea, los outliers de este dataset no son Pokémon más poderosos. Son Pokémon</a:t>
+            </a:r>
+          </a:p>
+          <a:p>
+            <a:r>
+              <a:t>desbalanceados. El juego reparte una cantidad fija de puntos, y si sos muy bueno en algo</a:t>
+            </a:r>
+          </a:p>
+          <a:p>
+            <a:r>
+              <a:t>lo pagás siendo muy malo en otra cosa."</a:t>
+            </a:r>
+          </a:p>
+          <a:p/>
+          <a:p>
+            <a:r>
+              <a:t>— NATURALEZA (quiénes son) —</a:t>
+            </a:r>
+          </a:p>
+          <a:p>
+            <a:r>
+              <a:t>"Después me puse a ver quiénes eran, porque eso es lo que decide si los saco o no."</a:t>
+            </a:r>
+          </a:p>
+          <a:p/>
+          <a:p>
+            <a:r>
+              <a:t>"El caso más extremo es Shedinja, que tiene 1 de vida. Es el único que queda por debajo</a:t>
+            </a:r>
+          </a:p>
+          <a:p>
+            <a:r>
+              <a:t>del límite en las 800 filas y en las seis stats. Y cuando lo busqué, resulta que no es un</a:t>
+            </a:r>
+          </a:p>
+          <a:p>
+            <a:r>
+              <a:t>error: en el juego tiene una habilidad que lo hace casi invulnerable, entonces le pusieron</a:t>
+            </a:r>
+          </a:p>
+          <a:p>
+            <a:r>
+              <a:t>1 de vida a propósito, para compensar."</a:t>
+            </a:r>
+          </a:p>
+          <a:p/>
+          <a:p>
+            <a:r>
+              <a:t>"Me pareció interesante eso: el dato más raro de todo el dataset está puesto ahí a</a:t>
+            </a:r>
+          </a:p>
+          <a:p>
+            <a:r>
+              <a:t>propósito."</a:t>
+            </a:r>
+          </a:p>
+          <a:p/>
+          <a:p>
+            <a:r>
               <a:t>— LA DECISIÓN —</a:t>
             </a:r>
           </a:p>
           <a:p>
             <a:r>
-              <a:t>"Por eso no los elimino. El 36,5 % de los outliers son legendarios, cuando en el dataset</a:t>
-            </a:r>
-          </a:p>
-          <a:p>
-            <a:r>
-              <a:t>entero son el 8,1 %: están 4,5 veces sobrerrepresentados. Ser extremo es lo que define a</a:t>
-            </a:r>
-          </a:p>
-          <a:p>
-            <a:r>
-              <a:t>un legendario. Si los borrara perdería 19 de los 65, el 29 % de la clase minoritaria."</a:t>
+              <a:t>"Y por eso decidí no eliminarlos. Por dos razones."</a:t>
             </a:r>
           </a:p>
           <a:p/>
           <a:p>
             <a:r>
-              <a:t>"Acá el outlier es la señal, no el ruido."</a:t>
+              <a:t>"Una, que ya la dije: no son errores, son casos reales."</a:t>
             </a:r>
           </a:p>
           <a:p/>
           <a:p>
             <a:r>
+              <a:t>"Y la otra, que me parece más fuerte: el 36,5 % de los outliers son legendarios, cuando en</a:t>
+            </a:r>
+          </a:p>
+          <a:p>
+            <a:r>
+              <a:t>el dataset entero los legendarios son el 8,1 %. O sea que están sobrerrepresentados cuatro</a:t>
+            </a:r>
+          </a:p>
+          <a:p>
+            <a:r>
+              <a:t>veces y media. Ser extremo es justamente lo que hace que un Pokémon sea legendario."</a:t>
+            </a:r>
+          </a:p>
+          <a:p/>
+          <a:p>
+            <a:r>
+              <a:t>"Si yo los borraba, me quedaba sin 19 de los 65 legendarios. Casi un tercio. Y en un</a:t>
+            </a:r>
+          </a:p>
+          <a:p>
+            <a:r>
+              <a:t>dataset que ya venía desbalanceado."</a:t>
+            </a:r>
+          </a:p>
+          <a:p/>
+          <a:p>
+            <a:r>
+              <a:t>"Así que acá el outlier no es ruido, es la señal."</a:t>
+            </a:r>
+          </a:p>
+          <a:p/>
+          <a:p>
+            <a:r>
               <a:t>— CIERRE —</a:t>
             </a:r>
           </a:p>
           <a:p>
             <a:r>
-              <a:t>"Y esa es la conclusión general: este dataset no tiene problemas de calidad, tiene</a:t>
-            </a:r>
-          </a:p>
-          <a:p>
-            <a:r>
-              <a:t>desafíos de estructura. Multicolinealidad, alta cardinalidad en los tipos, desbalance de</a:t>
-            </a:r>
-          </a:p>
-          <a:p>
-            <a:r>
-              <a:t>clase y casi-duplicados por las formas alternativas. Por eso las técnicas que propongo son</a:t>
-            </a:r>
-          </a:p>
-          <a:p>
-            <a:r>
-              <a:t>RobustScaler, split agrupado por número de Pokédex, y stratify con métricas F1 o recall."</a:t>
+              <a:t>"Y para cerrar: lo que aprendí de este dataset es que no tiene problemas de calidad, tiene</a:t>
+            </a:r>
+          </a:p>
+          <a:p>
+            <a:r>
+              <a:t>problemas de estructura. No hay datos mal cargados. Lo que hay es información repetida,</a:t>
+            </a:r>
+          </a:p>
+          <a:p>
+            <a:r>
+              <a:t>categorías con muy pocos casos, una clase desbalanceada, y filas que son casi duplicadas</a:t>
+            </a:r>
+          </a:p>
+          <a:p>
+            <a:r>
+              <a:t>entre sí."</a:t>
             </a:r>
           </a:p>
           <a:p/>
           <a:p>
             <a:r>
-              <a:t>"Gracias, quedo para preguntas."</a:t>
+              <a:t>"Por eso las técnicas que propondría son: escalar con RobustScaler, que usa la mediana en</a:t>
+            </a:r>
+          </a:p>
+          <a:p>
+            <a:r>
+              <a:t>vez del promedio; separar train y test agrupando por número de Pokédex, para que un</a:t>
+            </a:r>
+          </a:p>
+          <a:p>
+            <a:r>
+              <a:t>Pokémon y su Mega no queden de lados distintos; y usar F1 o recall en vez de accuracy, por</a:t>
+            </a:r>
+          </a:p>
+          <a:p>
+            <a:r>
+              <a:t>el desbalance."</a:t>
+            </a:r>
+          </a:p>
+          <a:p/>
+          <a:p>
+            <a:r>
+              <a:t>"Eso es todo. Gracias."</a:t>
             </a:r>
           </a:p>
         </p:txBody>

</xml_diff>